<commit_message>
chore: update newsletter with live data - 2026-05-22
</commit_message>
<xml_diff>
--- a/newsletter_20260522.pptx
+++ b/newsletter_20260522.pptx
@@ -4597,7 +4597,7 @@
                   <a:srgbClr val="212121"/>
                 </a:solidFill>
               </a:rPr>
-              <a:t>Turkey’s London Investor Pitch Gets Upended by Markets Tailspin</a:t>
+              <a:t>Trump Gets Another Ally in EU With Jansa’s Return in Slovenia</a:t>
             </a:r>
           </a:p>
         </p:txBody>
@@ -4763,7 +4763,7 @@
             <a:avLst/>
           </a:prstGeom>
           <a:solidFill>
-            <a:srgbClr val="E65C00"/>
+            <a:srgbClr val="2E7D32"/>
           </a:solidFill>
           <a:ln>
             <a:noFill/>
@@ -4801,6 +4801,228 @@
           <a:xfrm>
             <a:off x="8138160" y="1097280"/>
             <a:ext cx="640080" cy="274320"/>
+          </a:xfrm>
+          <a:prstGeom prst="rect">
+            <a:avLst/>
+          </a:prstGeom>
+          <a:solidFill>
+            <a:srgbClr val="2E7D32"/>
+          </a:solidFill>
+          <a:ln>
+            <a:noFill/>
+          </a:ln>
+        </p:spPr>
+        <p:style>
+          <a:lnRef idx="1">
+            <a:schemeClr val="accent1"/>
+          </a:lnRef>
+          <a:fillRef idx="3">
+            <a:schemeClr val="accent1"/>
+          </a:fillRef>
+          <a:effectRef idx="2">
+            <a:schemeClr val="accent1"/>
+          </a:effectRef>
+          <a:fontRef idx="minor">
+            <a:schemeClr val="lt1"/>
+          </a:fontRef>
+        </p:style>
+        <p:txBody>
+          <a:bodyPr rtlCol="0" anchor="ctr"/>
+          <a:lstStyle/>
+          <a:p>
+            <a:pPr algn="ctr"/>
+          </a:p>
+        </p:txBody>
+      </p:sp>
+      <p:sp>
+        <p:nvSpPr>
+          <p:cNvPr id="7" name="TextBox 6"/>
+          <p:cNvSpPr txBox="1"/>
+          <p:nvPr/>
+        </p:nvSpPr>
+        <p:spPr>
+          <a:xfrm>
+            <a:off x="8138160" y="1097280"/>
+            <a:ext cx="640080" cy="274320"/>
+          </a:xfrm>
+          <a:prstGeom prst="rect">
+            <a:avLst/>
+          </a:prstGeom>
+          <a:noFill/>
+        </p:spPr>
+        <p:txBody>
+          <a:bodyPr wrap="square">
+            <a:spAutoFit/>
+          </a:bodyPr>
+          <a:lstStyle/>
+          <a:p>
+            <a:pPr algn="ctr"/>
+            <a:r>
+              <a:rPr sz="900" b="1">
+                <a:solidFill>
+                  <a:srgbClr val="FFFFFF"/>
+                </a:solidFill>
+              </a:rPr>
+              <a:t>5/10</a:t>
+            </a:r>
+          </a:p>
+        </p:txBody>
+      </p:sp>
+      <p:sp>
+        <p:nvSpPr>
+          <p:cNvPr id="8" name="TextBox 7"/>
+          <p:cNvSpPr txBox="1"/>
+          <p:nvPr/>
+        </p:nvSpPr>
+        <p:spPr>
+          <a:xfrm>
+            <a:off x="457200" y="1097280"/>
+            <a:ext cx="7498080" cy="347472"/>
+          </a:xfrm>
+          <a:prstGeom prst="rect">
+            <a:avLst/>
+          </a:prstGeom>
+          <a:noFill/>
+        </p:spPr>
+        <p:txBody>
+          <a:bodyPr wrap="square">
+            <a:spAutoFit/>
+          </a:bodyPr>
+          <a:lstStyle/>
+          <a:p>
+            <a:pPr algn="l"/>
+            <a:r>
+              <a:rPr sz="1100" b="1">
+                <a:solidFill>
+                  <a:srgbClr val="212121"/>
+                </a:solidFill>
+              </a:rPr>
+              <a:t>Trump Gets Another Ally in EU With Jansa’s Return in Slovenia</a:t>
+            </a:r>
+          </a:p>
+        </p:txBody>
+      </p:sp>
+      <p:sp>
+        <p:nvSpPr>
+          <p:cNvPr id="9" name="TextBox 8"/>
+          <p:cNvSpPr txBox="1"/>
+          <p:nvPr/>
+        </p:nvSpPr>
+        <p:spPr>
+          <a:xfrm>
+            <a:off x="457200" y="1444752"/>
+            <a:ext cx="8321040" cy="502920"/>
+          </a:xfrm>
+          <a:prstGeom prst="rect">
+            <a:avLst/>
+          </a:prstGeom>
+          <a:noFill/>
+        </p:spPr>
+        <p:txBody>
+          <a:bodyPr wrap="square">
+            <a:spAutoFit/>
+          </a:bodyPr>
+          <a:lstStyle/>
+          <a:p>
+            <a:pPr algn="l"/>
+            <a:r>
+              <a:rPr sz="900" b="0">
+                <a:solidFill>
+                  <a:srgbClr val="757575"/>
+                </a:solidFill>
+              </a:rPr>
+              <a:t>Slovenian lawmakers elected nationalist leader Janez Jansa as the country’s next premier, tilting another European Union member to the right and handing Donald …</a:t>
+            </a:r>
+          </a:p>
+        </p:txBody>
+      </p:sp>
+      <p:sp>
+        <p:nvSpPr>
+          <p:cNvPr id="10" name="TextBox 9"/>
+          <p:cNvSpPr txBox="1"/>
+          <p:nvPr/>
+        </p:nvSpPr>
+        <p:spPr>
+          <a:xfrm>
+            <a:off x="457200" y="1965960"/>
+            <a:ext cx="3657600" cy="228600"/>
+          </a:xfrm>
+          <a:prstGeom prst="rect">
+            <a:avLst/>
+          </a:prstGeom>
+          <a:noFill/>
+        </p:spPr>
+        <p:txBody>
+          <a:bodyPr wrap="square">
+            <a:spAutoFit/>
+          </a:bodyPr>
+          <a:lstStyle/>
+          <a:p>
+            <a:pPr algn="l"/>
+            <a:r>
+              <a:rPr sz="800" b="0">
+                <a:solidFill>
+                  <a:srgbClr val="757575"/>
+                </a:solidFill>
+              </a:rPr>
+              <a:t>📰 feeds.bloomberg.com</a:t>
+            </a:r>
+          </a:p>
+        </p:txBody>
+      </p:sp>
+      <p:sp>
+        <p:nvSpPr>
+          <p:cNvPr id="11" name="Rectangle 10"/>
+          <p:cNvSpPr/>
+          <p:nvPr/>
+        </p:nvSpPr>
+        <p:spPr>
+          <a:xfrm>
+            <a:off x="274320" y="2350008"/>
+            <a:ext cx="8595360" cy="1234440"/>
+          </a:xfrm>
+          <a:prstGeom prst="rect">
+            <a:avLst/>
+          </a:prstGeom>
+          <a:solidFill>
+            <a:srgbClr val="FFFFFF"/>
+          </a:solidFill>
+          <a:ln>
+            <a:noFill/>
+          </a:ln>
+        </p:spPr>
+        <p:style>
+          <a:lnRef idx="1">
+            <a:schemeClr val="accent1"/>
+          </a:lnRef>
+          <a:fillRef idx="3">
+            <a:schemeClr val="accent1"/>
+          </a:fillRef>
+          <a:effectRef idx="2">
+            <a:schemeClr val="accent1"/>
+          </a:effectRef>
+          <a:fontRef idx="minor">
+            <a:schemeClr val="lt1"/>
+          </a:fontRef>
+        </p:style>
+        <p:txBody>
+          <a:bodyPr rtlCol="0" anchor="ctr"/>
+          <a:lstStyle/>
+          <a:p>
+            <a:pPr algn="ctr"/>
+          </a:p>
+        </p:txBody>
+      </p:sp>
+      <p:sp>
+        <p:nvSpPr>
+          <p:cNvPr id="12" name="Rectangle 11"/>
+          <p:cNvSpPr/>
+          <p:nvPr/>
+        </p:nvSpPr>
+        <p:spPr>
+          <a:xfrm>
+            <a:off x="274320" y="2350008"/>
+            <a:ext cx="54864" cy="1234440"/>
           </a:xfrm>
           <a:prstGeom prst="rect">
             <a:avLst/>
@@ -4836,13 +5058,56 @@
       </p:sp>
       <p:sp>
         <p:nvSpPr>
-          <p:cNvPr id="7" name="TextBox 6"/>
+          <p:cNvPr id="13" name="Rectangle 12"/>
+          <p:cNvSpPr/>
+          <p:nvPr/>
+        </p:nvSpPr>
+        <p:spPr>
+          <a:xfrm>
+            <a:off x="8138160" y="2441448"/>
+            <a:ext cx="640080" cy="274320"/>
+          </a:xfrm>
+          <a:prstGeom prst="rect">
+            <a:avLst/>
+          </a:prstGeom>
+          <a:solidFill>
+            <a:srgbClr val="E65C00"/>
+          </a:solidFill>
+          <a:ln>
+            <a:noFill/>
+          </a:ln>
+        </p:spPr>
+        <p:style>
+          <a:lnRef idx="1">
+            <a:schemeClr val="accent1"/>
+          </a:lnRef>
+          <a:fillRef idx="3">
+            <a:schemeClr val="accent1"/>
+          </a:fillRef>
+          <a:effectRef idx="2">
+            <a:schemeClr val="accent1"/>
+          </a:effectRef>
+          <a:fontRef idx="minor">
+            <a:schemeClr val="lt1"/>
+          </a:fontRef>
+        </p:style>
+        <p:txBody>
+          <a:bodyPr rtlCol="0" anchor="ctr"/>
+          <a:lstStyle/>
+          <a:p>
+            <a:pPr algn="ctr"/>
+          </a:p>
+        </p:txBody>
+      </p:sp>
+      <p:sp>
+        <p:nvSpPr>
+          <p:cNvPr id="14" name="TextBox 13"/>
           <p:cNvSpPr txBox="1"/>
           <p:nvPr/>
         </p:nvSpPr>
         <p:spPr>
           <a:xfrm>
-            <a:off x="8138160" y="1097280"/>
+            <a:off x="8138160" y="2441448"/>
             <a:ext cx="640080" cy="274320"/>
           </a:xfrm>
           <a:prstGeom prst="rect">
@@ -4870,13 +5135,13 @@
       </p:sp>
       <p:sp>
         <p:nvSpPr>
-          <p:cNvPr id="8" name="TextBox 7"/>
+          <p:cNvPr id="15" name="TextBox 14"/>
           <p:cNvSpPr txBox="1"/>
           <p:nvPr/>
         </p:nvSpPr>
         <p:spPr>
           <a:xfrm>
-            <a:off x="457200" y="1097280"/>
+            <a:off x="457200" y="2441448"/>
             <a:ext cx="7498080" cy="347472"/>
           </a:xfrm>
           <a:prstGeom prst="rect">
@@ -4904,13 +5169,13 @@
       </p:sp>
       <p:sp>
         <p:nvSpPr>
-          <p:cNvPr id="9" name="TextBox 8"/>
+          <p:cNvPr id="16" name="TextBox 15"/>
           <p:cNvSpPr txBox="1"/>
           <p:nvPr/>
         </p:nvSpPr>
         <p:spPr>
           <a:xfrm>
-            <a:off x="457200" y="1444752"/>
+            <a:off x="457200" y="2788920"/>
             <a:ext cx="8321040" cy="502920"/>
           </a:xfrm>
           <a:prstGeom prst="rect">
@@ -4938,13 +5203,13 @@
       </p:sp>
       <p:sp>
         <p:nvSpPr>
-          <p:cNvPr id="10" name="TextBox 9"/>
+          <p:cNvPr id="17" name="TextBox 16"/>
           <p:cNvSpPr txBox="1"/>
           <p:nvPr/>
         </p:nvSpPr>
         <p:spPr>
           <a:xfrm>
-            <a:off x="457200" y="1965960"/>
+            <a:off x="457200" y="3310128"/>
             <a:ext cx="3657600" cy="228600"/>
           </a:xfrm>
           <a:prstGeom prst="rect">
@@ -4972,13 +5237,13 @@
       </p:sp>
       <p:sp>
         <p:nvSpPr>
-          <p:cNvPr id="11" name="Rectangle 10"/>
+          <p:cNvPr id="18" name="Rectangle 17"/>
           <p:cNvSpPr/>
           <p:nvPr/>
         </p:nvSpPr>
         <p:spPr>
           <a:xfrm>
-            <a:off x="274320" y="2350008"/>
+            <a:off x="274320" y="3694176"/>
             <a:ext cx="8595360" cy="1234440"/>
           </a:xfrm>
           <a:prstGeom prst="rect">
@@ -5015,13 +5280,13 @@
       </p:sp>
       <p:sp>
         <p:nvSpPr>
-          <p:cNvPr id="12" name="Rectangle 11"/>
+          <p:cNvPr id="19" name="Rectangle 18"/>
           <p:cNvSpPr/>
           <p:nvPr/>
         </p:nvSpPr>
         <p:spPr>
           <a:xfrm>
-            <a:off x="274320" y="2350008"/>
+            <a:off x="274320" y="3694176"/>
             <a:ext cx="54864" cy="1234440"/>
           </a:xfrm>
           <a:prstGeom prst="rect">
@@ -5058,13 +5323,13 @@
       </p:sp>
       <p:sp>
         <p:nvSpPr>
-          <p:cNvPr id="13" name="Rectangle 12"/>
+          <p:cNvPr id="20" name="Rectangle 19"/>
           <p:cNvSpPr/>
           <p:nvPr/>
         </p:nvSpPr>
         <p:spPr>
           <a:xfrm>
-            <a:off x="8138160" y="2441448"/>
+            <a:off x="8138160" y="3785616"/>
             <a:ext cx="640080" cy="274320"/>
           </a:xfrm>
           <a:prstGeom prst="rect">
@@ -5101,13 +5366,13 @@
       </p:sp>
       <p:sp>
         <p:nvSpPr>
-          <p:cNvPr id="14" name="TextBox 13"/>
+          <p:cNvPr id="21" name="TextBox 20"/>
           <p:cNvSpPr txBox="1"/>
           <p:nvPr/>
         </p:nvSpPr>
         <p:spPr>
           <a:xfrm>
-            <a:off x="8138160" y="2441448"/>
+            <a:off x="8138160" y="3785616"/>
             <a:ext cx="640080" cy="274320"/>
           </a:xfrm>
           <a:prstGeom prst="rect">
@@ -5135,13 +5400,13 @@
       </p:sp>
       <p:sp>
         <p:nvSpPr>
-          <p:cNvPr id="15" name="TextBox 14"/>
+          <p:cNvPr id="22" name="TextBox 21"/>
           <p:cNvSpPr txBox="1"/>
           <p:nvPr/>
         </p:nvSpPr>
         <p:spPr>
           <a:xfrm>
-            <a:off x="457200" y="2441448"/>
+            <a:off x="457200" y="3785616"/>
             <a:ext cx="7498080" cy="347472"/>
           </a:xfrm>
           <a:prstGeom prst="rect">
@@ -5169,13 +5434,13 @@
       </p:sp>
       <p:sp>
         <p:nvSpPr>
-          <p:cNvPr id="16" name="TextBox 15"/>
+          <p:cNvPr id="23" name="TextBox 22"/>
           <p:cNvSpPr txBox="1"/>
           <p:nvPr/>
         </p:nvSpPr>
         <p:spPr>
           <a:xfrm>
-            <a:off x="457200" y="2788920"/>
+            <a:off x="457200" y="4133088"/>
             <a:ext cx="8321040" cy="502920"/>
           </a:xfrm>
           <a:prstGeom prst="rect">
@@ -5203,13 +5468,13 @@
       </p:sp>
       <p:sp>
         <p:nvSpPr>
-          <p:cNvPr id="17" name="TextBox 16"/>
+          <p:cNvPr id="24" name="TextBox 23"/>
           <p:cNvSpPr txBox="1"/>
           <p:nvPr/>
         </p:nvSpPr>
         <p:spPr>
           <a:xfrm>
-            <a:off x="457200" y="3310128"/>
+            <a:off x="457200" y="4654296"/>
             <a:ext cx="3657600" cy="228600"/>
           </a:xfrm>
           <a:prstGeom prst="rect">
@@ -5237,13 +5502,13 @@
       </p:sp>
       <p:sp>
         <p:nvSpPr>
-          <p:cNvPr id="18" name="Rectangle 17"/>
+          <p:cNvPr id="25" name="Rectangle 24"/>
           <p:cNvSpPr/>
           <p:nvPr/>
         </p:nvSpPr>
         <p:spPr>
           <a:xfrm>
-            <a:off x="274320" y="3694176"/>
+            <a:off x="274320" y="5038344"/>
             <a:ext cx="8595360" cy="1234440"/>
           </a:xfrm>
           <a:prstGeom prst="rect">
@@ -5280,13 +5545,13 @@
       </p:sp>
       <p:sp>
         <p:nvSpPr>
-          <p:cNvPr id="19" name="Rectangle 18"/>
+          <p:cNvPr id="26" name="Rectangle 25"/>
           <p:cNvSpPr/>
           <p:nvPr/>
         </p:nvSpPr>
         <p:spPr>
           <a:xfrm>
-            <a:off x="274320" y="3694176"/>
+            <a:off x="274320" y="5038344"/>
             <a:ext cx="54864" cy="1234440"/>
           </a:xfrm>
           <a:prstGeom prst="rect">
@@ -5323,13 +5588,13 @@
       </p:sp>
       <p:sp>
         <p:nvSpPr>
-          <p:cNvPr id="20" name="Rectangle 19"/>
+          <p:cNvPr id="27" name="Rectangle 26"/>
           <p:cNvSpPr/>
           <p:nvPr/>
         </p:nvSpPr>
         <p:spPr>
           <a:xfrm>
-            <a:off x="8138160" y="3785616"/>
+            <a:off x="8138160" y="5129784"/>
             <a:ext cx="640080" cy="274320"/>
           </a:xfrm>
           <a:prstGeom prst="rect">
@@ -5366,13 +5631,13 @@
       </p:sp>
       <p:sp>
         <p:nvSpPr>
-          <p:cNvPr id="21" name="TextBox 20"/>
+          <p:cNvPr id="28" name="TextBox 27"/>
           <p:cNvSpPr txBox="1"/>
           <p:nvPr/>
         </p:nvSpPr>
         <p:spPr>
           <a:xfrm>
-            <a:off x="8138160" y="3785616"/>
+            <a:off x="8138160" y="5129784"/>
             <a:ext cx="640080" cy="274320"/>
           </a:xfrm>
           <a:prstGeom prst="rect">
@@ -5400,13 +5665,13 @@
       </p:sp>
       <p:sp>
         <p:nvSpPr>
-          <p:cNvPr id="22" name="TextBox 21"/>
+          <p:cNvPr id="29" name="TextBox 28"/>
           <p:cNvSpPr txBox="1"/>
           <p:nvPr/>
         </p:nvSpPr>
         <p:spPr>
           <a:xfrm>
-            <a:off x="457200" y="3785616"/>
+            <a:off x="457200" y="5129784"/>
             <a:ext cx="7498080" cy="347472"/>
           </a:xfrm>
           <a:prstGeom prst="rect">
@@ -5434,13 +5699,13 @@
       </p:sp>
       <p:sp>
         <p:nvSpPr>
-          <p:cNvPr id="23" name="TextBox 22"/>
+          <p:cNvPr id="30" name="TextBox 29"/>
           <p:cNvSpPr txBox="1"/>
           <p:nvPr/>
         </p:nvSpPr>
         <p:spPr>
           <a:xfrm>
-            <a:off x="457200" y="4133088"/>
+            <a:off x="457200" y="5477256"/>
             <a:ext cx="8321040" cy="502920"/>
           </a:xfrm>
           <a:prstGeom prst="rect">
@@ -5462,271 +5727,6 @@
                 </a:solidFill>
               </a:rPr>
               <a:t>The Royal International Air Tattoo at RAF Fairford, the UK’s biggest military air show, has been canceled this summer because US aircraft are using the venue fo…</a:t>
-            </a:r>
-          </a:p>
-        </p:txBody>
-      </p:sp>
-      <p:sp>
-        <p:nvSpPr>
-          <p:cNvPr id="24" name="TextBox 23"/>
-          <p:cNvSpPr txBox="1"/>
-          <p:nvPr/>
-        </p:nvSpPr>
-        <p:spPr>
-          <a:xfrm>
-            <a:off x="457200" y="4654296"/>
-            <a:ext cx="3657600" cy="228600"/>
-          </a:xfrm>
-          <a:prstGeom prst="rect">
-            <a:avLst/>
-          </a:prstGeom>
-          <a:noFill/>
-        </p:spPr>
-        <p:txBody>
-          <a:bodyPr wrap="square">
-            <a:spAutoFit/>
-          </a:bodyPr>
-          <a:lstStyle/>
-          <a:p>
-            <a:pPr algn="l"/>
-            <a:r>
-              <a:rPr sz="800" b="0">
-                <a:solidFill>
-                  <a:srgbClr val="757575"/>
-                </a:solidFill>
-              </a:rPr>
-              <a:t>📰 feeds.bloomberg.com</a:t>
-            </a:r>
-          </a:p>
-        </p:txBody>
-      </p:sp>
-      <p:sp>
-        <p:nvSpPr>
-          <p:cNvPr id="25" name="Rectangle 24"/>
-          <p:cNvSpPr/>
-          <p:nvPr/>
-        </p:nvSpPr>
-        <p:spPr>
-          <a:xfrm>
-            <a:off x="274320" y="5038344"/>
-            <a:ext cx="8595360" cy="1234440"/>
-          </a:xfrm>
-          <a:prstGeom prst="rect">
-            <a:avLst/>
-          </a:prstGeom>
-          <a:solidFill>
-            <a:srgbClr val="FFFFFF"/>
-          </a:solidFill>
-          <a:ln>
-            <a:noFill/>
-          </a:ln>
-        </p:spPr>
-        <p:style>
-          <a:lnRef idx="1">
-            <a:schemeClr val="accent1"/>
-          </a:lnRef>
-          <a:fillRef idx="3">
-            <a:schemeClr val="accent1"/>
-          </a:fillRef>
-          <a:effectRef idx="2">
-            <a:schemeClr val="accent1"/>
-          </a:effectRef>
-          <a:fontRef idx="minor">
-            <a:schemeClr val="lt1"/>
-          </a:fontRef>
-        </p:style>
-        <p:txBody>
-          <a:bodyPr rtlCol="0" anchor="ctr"/>
-          <a:lstStyle/>
-          <a:p>
-            <a:pPr algn="ctr"/>
-          </a:p>
-        </p:txBody>
-      </p:sp>
-      <p:sp>
-        <p:nvSpPr>
-          <p:cNvPr id="26" name="Rectangle 25"/>
-          <p:cNvSpPr/>
-          <p:nvPr/>
-        </p:nvSpPr>
-        <p:spPr>
-          <a:xfrm>
-            <a:off x="274320" y="5038344"/>
-            <a:ext cx="54864" cy="1234440"/>
-          </a:xfrm>
-          <a:prstGeom prst="rect">
-            <a:avLst/>
-          </a:prstGeom>
-          <a:solidFill>
-            <a:srgbClr val="2E7D32"/>
-          </a:solidFill>
-          <a:ln>
-            <a:noFill/>
-          </a:ln>
-        </p:spPr>
-        <p:style>
-          <a:lnRef idx="1">
-            <a:schemeClr val="accent1"/>
-          </a:lnRef>
-          <a:fillRef idx="3">
-            <a:schemeClr val="accent1"/>
-          </a:fillRef>
-          <a:effectRef idx="2">
-            <a:schemeClr val="accent1"/>
-          </a:effectRef>
-          <a:fontRef idx="minor">
-            <a:schemeClr val="lt1"/>
-          </a:fontRef>
-        </p:style>
-        <p:txBody>
-          <a:bodyPr rtlCol="0" anchor="ctr"/>
-          <a:lstStyle/>
-          <a:p>
-            <a:pPr algn="ctr"/>
-          </a:p>
-        </p:txBody>
-      </p:sp>
-      <p:sp>
-        <p:nvSpPr>
-          <p:cNvPr id="27" name="Rectangle 26"/>
-          <p:cNvSpPr/>
-          <p:nvPr/>
-        </p:nvSpPr>
-        <p:spPr>
-          <a:xfrm>
-            <a:off x="8138160" y="5129784"/>
-            <a:ext cx="640080" cy="274320"/>
-          </a:xfrm>
-          <a:prstGeom prst="rect">
-            <a:avLst/>
-          </a:prstGeom>
-          <a:solidFill>
-            <a:srgbClr val="2E7D32"/>
-          </a:solidFill>
-          <a:ln>
-            <a:noFill/>
-          </a:ln>
-        </p:spPr>
-        <p:style>
-          <a:lnRef idx="1">
-            <a:schemeClr val="accent1"/>
-          </a:lnRef>
-          <a:fillRef idx="3">
-            <a:schemeClr val="accent1"/>
-          </a:fillRef>
-          <a:effectRef idx="2">
-            <a:schemeClr val="accent1"/>
-          </a:effectRef>
-          <a:fontRef idx="minor">
-            <a:schemeClr val="lt1"/>
-          </a:fontRef>
-        </p:style>
-        <p:txBody>
-          <a:bodyPr rtlCol="0" anchor="ctr"/>
-          <a:lstStyle/>
-          <a:p>
-            <a:pPr algn="ctr"/>
-          </a:p>
-        </p:txBody>
-      </p:sp>
-      <p:sp>
-        <p:nvSpPr>
-          <p:cNvPr id="28" name="TextBox 27"/>
-          <p:cNvSpPr txBox="1"/>
-          <p:nvPr/>
-        </p:nvSpPr>
-        <p:spPr>
-          <a:xfrm>
-            <a:off x="8138160" y="5129784"/>
-            <a:ext cx="640080" cy="274320"/>
-          </a:xfrm>
-          <a:prstGeom prst="rect">
-            <a:avLst/>
-          </a:prstGeom>
-          <a:noFill/>
-        </p:spPr>
-        <p:txBody>
-          <a:bodyPr wrap="square">
-            <a:spAutoFit/>
-          </a:bodyPr>
-          <a:lstStyle/>
-          <a:p>
-            <a:pPr algn="ctr"/>
-            <a:r>
-              <a:rPr sz="900" b="1">
-                <a:solidFill>
-                  <a:srgbClr val="FFFFFF"/>
-                </a:solidFill>
-              </a:rPr>
-              <a:t>5/10</a:t>
-            </a:r>
-          </a:p>
-        </p:txBody>
-      </p:sp>
-      <p:sp>
-        <p:nvSpPr>
-          <p:cNvPr id="29" name="TextBox 28"/>
-          <p:cNvSpPr txBox="1"/>
-          <p:nvPr/>
-        </p:nvSpPr>
-        <p:spPr>
-          <a:xfrm>
-            <a:off x="457200" y="5129784"/>
-            <a:ext cx="7498080" cy="347472"/>
-          </a:xfrm>
-          <a:prstGeom prst="rect">
-            <a:avLst/>
-          </a:prstGeom>
-          <a:noFill/>
-        </p:spPr>
-        <p:txBody>
-          <a:bodyPr wrap="square">
-            <a:spAutoFit/>
-          </a:bodyPr>
-          <a:lstStyle/>
-          <a:p>
-            <a:pPr algn="l"/>
-            <a:r>
-              <a:rPr sz="1100" b="1">
-                <a:solidFill>
-                  <a:srgbClr val="212121"/>
-                </a:solidFill>
-              </a:rPr>
-              <a:t>Turkey’s London Investor Pitch Gets Upended by Markets Tailspin</a:t>
-            </a:r>
-          </a:p>
-        </p:txBody>
-      </p:sp>
-      <p:sp>
-        <p:nvSpPr>
-          <p:cNvPr id="30" name="TextBox 29"/>
-          <p:cNvSpPr txBox="1"/>
-          <p:nvPr/>
-        </p:nvSpPr>
-        <p:spPr>
-          <a:xfrm>
-            <a:off x="457200" y="5477256"/>
-            <a:ext cx="8321040" cy="502920"/>
-          </a:xfrm>
-          <a:prstGeom prst="rect">
-            <a:avLst/>
-          </a:prstGeom>
-          <a:noFill/>
-        </p:spPr>
-        <p:txBody>
-          <a:bodyPr wrap="square">
-            <a:spAutoFit/>
-          </a:bodyPr>
-          <a:lstStyle/>
-          <a:p>
-            <a:pPr algn="l"/>
-            <a:r>
-              <a:rPr sz="900" b="0">
-                <a:solidFill>
-                  <a:srgbClr val="757575"/>
-                </a:solidFill>
-              </a:rPr>
-              <a:t>With a packed schedule of meetings and speeches in front of London investors, Turkey’s top economic officials set out on Thursday to ease concerns about the cou…</a:t>
             </a:r>
           </a:p>
         </p:txBody>

</xml_diff>